<commit_message>
penalti tidak memberi penilaian
</commit_message>
<xml_diff>
--- a/rubrikETS.pptx
+++ b/rubrikETS.pptx
@@ -141,7 +141,7 @@
       </p:grpSpPr>
       <p:sp>
         <p:nvSpPr>
-          <p:cNvPr id="94901275" name="Header Placeholder 1"/>
+          <p:cNvPr id="188538997" name="Header Placeholder 1"/>
           <p:cNvSpPr>
             <a:spLocks noGrp="1"/>
           </p:cNvSpPr>
@@ -175,7 +175,7 @@
       </p:sp>
       <p:sp>
         <p:nvSpPr>
-          <p:cNvPr id="1249202975" name="Date Placeholder 2"/>
+          <p:cNvPr id="283794699" name="Date Placeholder 2"/>
           <p:cNvSpPr>
             <a:spLocks noGrp="1"/>
           </p:cNvSpPr>
@@ -213,7 +213,7 @@
       </p:sp>
       <p:sp>
         <p:nvSpPr>
-          <p:cNvPr id="711969050" name="Slide Image Placeholder 3"/>
+          <p:cNvPr id="1609653427" name="Slide Image Placeholder 3"/>
           <p:cNvSpPr>
             <a:spLocks noChangeAspect="1" noGrp="1" noRot="1"/>
           </p:cNvSpPr>
@@ -249,7 +249,7 @@
       </p:sp>
       <p:sp>
         <p:nvSpPr>
-          <p:cNvPr id="1210642693" name="Notes Placeholder 4"/>
+          <p:cNvPr id="1969107531" name="Notes Placeholder 4"/>
           <p:cNvSpPr>
             <a:spLocks noGrp="1"/>
           </p:cNvSpPr>
@@ -323,7 +323,7 @@
       </p:sp>
       <p:sp>
         <p:nvSpPr>
-          <p:cNvPr id="11869857" name="Footer Placeholder 5"/>
+          <p:cNvPr id="1614509468" name="Footer Placeholder 5"/>
           <p:cNvSpPr>
             <a:spLocks noGrp="1"/>
           </p:cNvSpPr>
@@ -357,7 +357,7 @@
       </p:sp>
       <p:sp>
         <p:nvSpPr>
-          <p:cNvPr id="180546306" name="Slide Number Placeholder 6"/>
+          <p:cNvPr id="1458006703" name="Slide Number Placeholder 6"/>
           <p:cNvSpPr>
             <a:spLocks noGrp="1"/>
           </p:cNvSpPr>
@@ -510,7 +510,7 @@
       </p:grpSpPr>
       <p:sp>
         <p:nvSpPr>
-          <p:cNvPr id="1992624308" name="Slide Image Placeholder 1"/>
+          <p:cNvPr id="1935007317" name="Slide Image Placeholder 1"/>
           <p:cNvSpPr>
             <a:spLocks noChangeAspect="1" noGrp="1" noRot="1"/>
           </p:cNvSpPr>
@@ -527,7 +527,7 @@
       </p:sp>
       <p:sp>
         <p:nvSpPr>
-          <p:cNvPr id="265049942" name="Notes Placeholder 2"/>
+          <p:cNvPr id="566465449" name="Notes Placeholder 2"/>
           <p:cNvSpPr>
             <a:spLocks noGrp="1"/>
           </p:cNvSpPr>
@@ -552,7 +552,7 @@
       </p:sp>
       <p:sp>
         <p:nvSpPr>
-          <p:cNvPr id="82197310" name="Slide Number Placeholder 3"/>
+          <p:cNvPr id="1934909019" name="Slide Number Placeholder 3"/>
           <p:cNvSpPr>
             <a:spLocks noGrp="1"/>
           </p:cNvSpPr>
@@ -603,7 +603,7 @@
       </p:grpSpPr>
       <p:sp>
         <p:nvSpPr>
-          <p:cNvPr id="1222881398" name="Slide Image Placeholder 1"/>
+          <p:cNvPr id="55974911" name="Slide Image Placeholder 1"/>
           <p:cNvSpPr>
             <a:spLocks noChangeAspect="1" noGrp="1" noRot="1"/>
           </p:cNvSpPr>
@@ -615,7 +615,7 @@
       </p:sp>
       <p:sp>
         <p:nvSpPr>
-          <p:cNvPr id="29857699" name="Notes Placeholder 2"/>
+          <p:cNvPr id="171561693" name="Notes Placeholder 2"/>
           <p:cNvSpPr>
             <a:spLocks noGrp="1"/>
           </p:cNvSpPr>
@@ -637,7 +637,7 @@
       </p:sp>
       <p:sp>
         <p:nvSpPr>
-          <p:cNvPr id="1047651387" name="Slide Number Placeholder 3"/>
+          <p:cNvPr id="389327349" name="Slide Number Placeholder 3"/>
           <p:cNvSpPr>
             <a:spLocks noGrp="1"/>
           </p:cNvSpPr>
@@ -688,7 +688,7 @@
       </p:grpSpPr>
       <p:sp>
         <p:nvSpPr>
-          <p:cNvPr id="706624908" name="Slide Image Placeholder 1"/>
+          <p:cNvPr id="1704940093" name="Slide Image Placeholder 1"/>
           <p:cNvSpPr>
             <a:spLocks noChangeAspect="1" noGrp="1" noRot="1"/>
           </p:cNvSpPr>
@@ -700,7 +700,7 @@
       </p:sp>
       <p:sp>
         <p:nvSpPr>
-          <p:cNvPr id="1160298163" name="Notes Placeholder 2"/>
+          <p:cNvPr id="704869399" name="Notes Placeholder 2"/>
           <p:cNvSpPr>
             <a:spLocks noGrp="1"/>
           </p:cNvSpPr>
@@ -722,7 +722,7 @@
       </p:sp>
       <p:sp>
         <p:nvSpPr>
-          <p:cNvPr id="2141883703" name="Slide Number Placeholder 3"/>
+          <p:cNvPr id="1935178033" name="Slide Number Placeholder 3"/>
           <p:cNvSpPr>
             <a:spLocks noGrp="1"/>
           </p:cNvSpPr>
@@ -773,7 +773,7 @@
       </p:grpSpPr>
       <p:sp>
         <p:nvSpPr>
-          <p:cNvPr id="121435091" name="Slide Image Placeholder 1"/>
+          <p:cNvPr id="1361158008" name="Slide Image Placeholder 1"/>
           <p:cNvSpPr>
             <a:spLocks noChangeAspect="1" noGrp="1" noRot="1"/>
           </p:cNvSpPr>
@@ -785,7 +785,7 @@
       </p:sp>
       <p:sp>
         <p:nvSpPr>
-          <p:cNvPr id="145884490" name="Notes Placeholder 2"/>
+          <p:cNvPr id="2116281625" name="Notes Placeholder 2"/>
           <p:cNvSpPr>
             <a:spLocks noGrp="1"/>
           </p:cNvSpPr>
@@ -807,7 +807,7 @@
       </p:sp>
       <p:sp>
         <p:nvSpPr>
-          <p:cNvPr id="1881100436" name="Slide Number Placeholder 3"/>
+          <p:cNvPr id="199155423" name="Slide Number Placeholder 3"/>
           <p:cNvSpPr>
             <a:spLocks noGrp="1"/>
           </p:cNvSpPr>
@@ -858,7 +858,7 @@
       </p:grpSpPr>
       <p:sp>
         <p:nvSpPr>
-          <p:cNvPr id="1432097629" name="Slide Image Placeholder 1"/>
+          <p:cNvPr id="1979804486" name="Slide Image Placeholder 1"/>
           <p:cNvSpPr>
             <a:spLocks noChangeAspect="1" noGrp="1" noRot="1"/>
           </p:cNvSpPr>
@@ -870,7 +870,7 @@
       </p:sp>
       <p:sp>
         <p:nvSpPr>
-          <p:cNvPr id="379373038" name="Notes Placeholder 2"/>
+          <p:cNvPr id="468662442" name="Notes Placeholder 2"/>
           <p:cNvSpPr>
             <a:spLocks noGrp="1"/>
           </p:cNvSpPr>
@@ -892,7 +892,7 @@
       </p:sp>
       <p:sp>
         <p:nvSpPr>
-          <p:cNvPr id="1391296464" name="Slide Number Placeholder 3"/>
+          <p:cNvPr id="1339671381" name="Slide Number Placeholder 3"/>
           <p:cNvSpPr>
             <a:spLocks noGrp="1"/>
           </p:cNvSpPr>
@@ -943,7 +943,7 @@
       </p:grpSpPr>
       <p:sp>
         <p:nvSpPr>
-          <p:cNvPr id="1244645747" name="Slide Image Placeholder 1"/>
+          <p:cNvPr id="1253397196" name="Slide Image Placeholder 1"/>
           <p:cNvSpPr>
             <a:spLocks noChangeAspect="1" noGrp="1" noRot="1"/>
           </p:cNvSpPr>
@@ -955,7 +955,7 @@
       </p:sp>
       <p:sp>
         <p:nvSpPr>
-          <p:cNvPr id="1545397774" name="Notes Placeholder 2"/>
+          <p:cNvPr id="1803826488" name="Notes Placeholder 2"/>
           <p:cNvSpPr>
             <a:spLocks noGrp="1"/>
           </p:cNvSpPr>
@@ -977,7 +977,7 @@
       </p:sp>
       <p:sp>
         <p:nvSpPr>
-          <p:cNvPr id="1461658771" name="Slide Number Placeholder 3"/>
+          <p:cNvPr id="859798717" name="Slide Number Placeholder 3"/>
           <p:cNvSpPr>
             <a:spLocks noGrp="1"/>
           </p:cNvSpPr>
@@ -1028,7 +1028,7 @@
       </p:grpSpPr>
       <p:sp>
         <p:nvSpPr>
-          <p:cNvPr id="1394545204" name="Slide Image Placeholder 1"/>
+          <p:cNvPr id="1893444442" name="Slide Image Placeholder 1"/>
           <p:cNvSpPr>
             <a:spLocks noChangeAspect="1" noGrp="1" noRot="1"/>
           </p:cNvSpPr>
@@ -1040,7 +1040,7 @@
       </p:sp>
       <p:sp>
         <p:nvSpPr>
-          <p:cNvPr id="802865947" name="Notes Placeholder 2"/>
+          <p:cNvPr id="225789367" name="Notes Placeholder 2"/>
           <p:cNvSpPr>
             <a:spLocks noGrp="1"/>
           </p:cNvSpPr>
@@ -1062,7 +1062,7 @@
       </p:sp>
       <p:sp>
         <p:nvSpPr>
-          <p:cNvPr id="1318428950" name="Slide Number Placeholder 3"/>
+          <p:cNvPr id="61852400" name="Slide Number Placeholder 3"/>
           <p:cNvSpPr>
             <a:spLocks noGrp="1"/>
           </p:cNvSpPr>
@@ -1113,7 +1113,7 @@
       </p:grpSpPr>
       <p:sp>
         <p:nvSpPr>
-          <p:cNvPr id="270945092" name="Slide Image Placeholder 1"/>
+          <p:cNvPr id="1827987300" name="Slide Image Placeholder 1"/>
           <p:cNvSpPr>
             <a:spLocks noChangeAspect="1" noGrp="1" noRot="1"/>
           </p:cNvSpPr>
@@ -1125,7 +1125,7 @@
       </p:sp>
       <p:sp>
         <p:nvSpPr>
-          <p:cNvPr id="505956634" name="Notes Placeholder 2"/>
+          <p:cNvPr id="1706801608" name="Notes Placeholder 2"/>
           <p:cNvSpPr>
             <a:spLocks noGrp="1"/>
           </p:cNvSpPr>
@@ -1147,7 +1147,7 @@
       </p:sp>
       <p:sp>
         <p:nvSpPr>
-          <p:cNvPr id="1352118178" name="Slide Number Placeholder 3"/>
+          <p:cNvPr id="928355751" name="Slide Number Placeholder 3"/>
           <p:cNvSpPr>
             <a:spLocks noGrp="1"/>
           </p:cNvSpPr>
@@ -1198,7 +1198,7 @@
       </p:grpSpPr>
       <p:sp>
         <p:nvSpPr>
-          <p:cNvPr id="84610531" name="Shape 1059"/>
+          <p:cNvPr id="417396993" name="Shape 1059"/>
           <p:cNvSpPr>
             <a:spLocks noChangeArrowheads="1" noGrp="1"/>
           </p:cNvSpPr>
@@ -1321,7 +1321,7 @@
       </p:sp>
       <p:sp>
         <p:nvSpPr>
-          <p:cNvPr id="901723592" name="Shape 1060"/>
+          <p:cNvPr id="978389618" name="Shape 1060"/>
           <p:cNvSpPr>
             <a:spLocks noChangeArrowheads="1" noGrp="1"/>
           </p:cNvSpPr>
@@ -1412,7 +1412,7 @@
       </p:sp>
       <p:sp>
         <p:nvSpPr>
-          <p:cNvPr id="2016962568" name="Shape 1061"/>
+          <p:cNvPr id="1426958506" name="Shape 1061"/>
           <p:cNvSpPr>
             <a:spLocks noChangeArrowheads="1" noGrp="1"/>
           </p:cNvSpPr>
@@ -1498,7 +1498,7 @@
       </p:sp>
       <p:sp>
         <p:nvSpPr>
-          <p:cNvPr id="234492519" name="Shape 1062"/>
+          <p:cNvPr id="1133383384" name="Shape 1062"/>
           <p:cNvSpPr>
             <a:spLocks noChangeArrowheads="1" noGrp="1"/>
           </p:cNvSpPr>
@@ -1576,7 +1576,7 @@
       </p:sp>
       <p:sp>
         <p:nvSpPr>
-          <p:cNvPr id="1402196417" name="Shape 1063"/>
+          <p:cNvPr id="1064800638" name="Shape 1063"/>
           <p:cNvSpPr>
             <a:spLocks noChangeArrowheads="1" noGrp="1"/>
           </p:cNvSpPr>
@@ -1654,7 +1654,7 @@
       </p:sp>
       <p:sp>
         <p:nvSpPr>
-          <p:cNvPr id="314818968" name="Subtitle 2"/>
+          <p:cNvPr id="61600099" name="Subtitle 2"/>
           <p:cNvSpPr>
             <a:spLocks noGrp="1"/>
           </p:cNvSpPr>
@@ -1777,7 +1777,7 @@
       </p:sp>
       <p:sp>
         <p:nvSpPr>
-          <p:cNvPr id="161225824" name="Date Placeholder 3"/>
+          <p:cNvPr id="1667652134" name="Date Placeholder 3"/>
           <p:cNvSpPr>
             <a:spLocks noGrp="1"/>
           </p:cNvSpPr>
@@ -1803,7 +1803,7 @@
       </p:sp>
       <p:sp>
         <p:nvSpPr>
-          <p:cNvPr id="854724660" name="Footer Placeholder 4"/>
+          <p:cNvPr id="798566830" name="Footer Placeholder 4"/>
           <p:cNvSpPr>
             <a:spLocks noGrp="1"/>
           </p:cNvSpPr>
@@ -1825,7 +1825,7 @@
       </p:sp>
       <p:sp>
         <p:nvSpPr>
-          <p:cNvPr id="1027550752" name="Slide Number Placeholder 5"/>
+          <p:cNvPr id="311572081" name="Slide Number Placeholder 5"/>
           <p:cNvSpPr>
             <a:spLocks noGrp="1"/>
           </p:cNvSpPr>
@@ -1851,7 +1851,7 @@
       </p:sp>
       <p:sp>
         <p:nvSpPr>
-          <p:cNvPr id="138303879" name="Title 6"/>
+          <p:cNvPr id="711966018" name="Title 6"/>
           <p:cNvSpPr>
             <a:spLocks noGrp="1"/>
           </p:cNvSpPr>
@@ -1911,7 +1911,7 @@
       </p:grpSpPr>
       <p:sp>
         <p:nvSpPr>
-          <p:cNvPr id="1173112230" name="Title 1"/>
+          <p:cNvPr id="298514161" name="Title 1"/>
           <p:cNvSpPr>
             <a:spLocks noGrp="1"/>
           </p:cNvSpPr>
@@ -1937,7 +1937,7 @@
       </p:sp>
       <p:sp>
         <p:nvSpPr>
-          <p:cNvPr id="1934272057" name="Vertical Text Placeholder 2"/>
+          <p:cNvPr id="1232676987" name="Vertical Text Placeholder 2"/>
           <p:cNvSpPr>
             <a:spLocks noGrp="1"/>
           </p:cNvSpPr>
@@ -2003,7 +2003,7 @@
       </p:sp>
       <p:sp>
         <p:nvSpPr>
-          <p:cNvPr id="1978549232" name="Date Placeholder 3"/>
+          <p:cNvPr id="1843067494" name="Date Placeholder 3"/>
           <p:cNvSpPr>
             <a:spLocks noGrp="1"/>
           </p:cNvSpPr>
@@ -2029,7 +2029,7 @@
       </p:sp>
       <p:sp>
         <p:nvSpPr>
-          <p:cNvPr id="158781516" name="Footer Placeholder 4"/>
+          <p:cNvPr id="1784807401" name="Footer Placeholder 4"/>
           <p:cNvSpPr>
             <a:spLocks noGrp="1"/>
           </p:cNvSpPr>
@@ -2051,7 +2051,7 @@
       </p:sp>
       <p:sp>
         <p:nvSpPr>
-          <p:cNvPr id="894720439" name="Slide Number Placeholder 5"/>
+          <p:cNvPr id="2003243039" name="Slide Number Placeholder 5"/>
           <p:cNvSpPr>
             <a:spLocks noGrp="1"/>
           </p:cNvSpPr>
@@ -2102,7 +2102,7 @@
       </p:grpSpPr>
       <p:sp>
         <p:nvSpPr>
-          <p:cNvPr id="1372393624" name="Vertical Title 1"/>
+          <p:cNvPr id="893844139" name="Vertical Title 1"/>
           <p:cNvSpPr>
             <a:spLocks noGrp="1"/>
           </p:cNvSpPr>
@@ -2137,7 +2137,7 @@
       </p:sp>
       <p:sp>
         <p:nvSpPr>
-          <p:cNvPr id="1150805579" name="Vertical Text Placeholder 2"/>
+          <p:cNvPr id="1077319282" name="Vertical Text Placeholder 2"/>
           <p:cNvSpPr>
             <a:spLocks noGrp="1"/>
           </p:cNvSpPr>
@@ -2208,7 +2208,7 @@
       </p:sp>
       <p:sp>
         <p:nvSpPr>
-          <p:cNvPr id="244530018" name="Date Placeholder 3"/>
+          <p:cNvPr id="414112602" name="Date Placeholder 3"/>
           <p:cNvSpPr>
             <a:spLocks noGrp="1"/>
           </p:cNvSpPr>
@@ -2234,7 +2234,7 @@
       </p:sp>
       <p:sp>
         <p:nvSpPr>
-          <p:cNvPr id="844334437" name="Footer Placeholder 4"/>
+          <p:cNvPr id="88229974" name="Footer Placeholder 4"/>
           <p:cNvSpPr>
             <a:spLocks noGrp="1"/>
           </p:cNvSpPr>
@@ -2256,7 +2256,7 @@
       </p:sp>
       <p:sp>
         <p:nvSpPr>
-          <p:cNvPr id="566969059" name="Slide Number Placeholder 5"/>
+          <p:cNvPr id="1857243497" name="Slide Number Placeholder 5"/>
           <p:cNvSpPr>
             <a:spLocks noGrp="1"/>
           </p:cNvSpPr>
@@ -2307,7 +2307,7 @@
       </p:grpSpPr>
       <p:sp>
         <p:nvSpPr>
-          <p:cNvPr id="2141949683" name="Title 1"/>
+          <p:cNvPr id="1549875813" name="Title 1"/>
           <p:cNvSpPr>
             <a:spLocks noGrp="1"/>
           </p:cNvSpPr>
@@ -2333,7 +2333,7 @@
       </p:sp>
       <p:sp>
         <p:nvSpPr>
-          <p:cNvPr id="56889696" name="Content Placeholder 2"/>
+          <p:cNvPr id="2085994951" name="Content Placeholder 2"/>
           <p:cNvSpPr>
             <a:spLocks noGrp="1"/>
           </p:cNvSpPr>
@@ -2399,7 +2399,7 @@
       </p:sp>
       <p:sp>
         <p:nvSpPr>
-          <p:cNvPr id="649544214" name="Date Placeholder 3"/>
+          <p:cNvPr id="382801725" name="Date Placeholder 3"/>
           <p:cNvSpPr>
             <a:spLocks noGrp="1"/>
           </p:cNvSpPr>
@@ -2425,7 +2425,7 @@
       </p:sp>
       <p:sp>
         <p:nvSpPr>
-          <p:cNvPr id="141471638" name="Footer Placeholder 4"/>
+          <p:cNvPr id="246179888" name="Footer Placeholder 4"/>
           <p:cNvSpPr>
             <a:spLocks noGrp="1"/>
           </p:cNvSpPr>
@@ -2447,7 +2447,7 @@
       </p:sp>
       <p:sp>
         <p:nvSpPr>
-          <p:cNvPr id="920856246" name="Slide Number Placeholder 5"/>
+          <p:cNvPr id="543656543" name="Slide Number Placeholder 5"/>
           <p:cNvSpPr>
             <a:spLocks noGrp="1"/>
           </p:cNvSpPr>
@@ -2498,7 +2498,7 @@
       </p:grpSpPr>
       <p:sp>
         <p:nvSpPr>
-          <p:cNvPr id="1111082098" name="Title 1"/>
+          <p:cNvPr id="242090428" name="Title 1"/>
           <p:cNvSpPr>
             <a:spLocks noGrp="1"/>
           </p:cNvSpPr>
@@ -2533,7 +2533,7 @@
       </p:sp>
       <p:sp>
         <p:nvSpPr>
-          <p:cNvPr id="1025625018" name="Text Placeholder 2"/>
+          <p:cNvPr id="68192721" name="Text Placeholder 2"/>
           <p:cNvSpPr>
             <a:spLocks noGrp="1"/>
           </p:cNvSpPr>
@@ -2655,7 +2655,7 @@
       </p:sp>
       <p:sp>
         <p:nvSpPr>
-          <p:cNvPr id="456380698" name="Date Placeholder 3"/>
+          <p:cNvPr id="260701519" name="Date Placeholder 3"/>
           <p:cNvSpPr>
             <a:spLocks noGrp="1"/>
           </p:cNvSpPr>
@@ -2681,7 +2681,7 @@
       </p:sp>
       <p:sp>
         <p:nvSpPr>
-          <p:cNvPr id="996384650" name="Footer Placeholder 4"/>
+          <p:cNvPr id="1003634035" name="Footer Placeholder 4"/>
           <p:cNvSpPr>
             <a:spLocks noGrp="1"/>
           </p:cNvSpPr>
@@ -2703,7 +2703,7 @@
       </p:sp>
       <p:sp>
         <p:nvSpPr>
-          <p:cNvPr id="983677052" name="Slide Number Placeholder 5"/>
+          <p:cNvPr id="1602247440" name="Slide Number Placeholder 5"/>
           <p:cNvSpPr>
             <a:spLocks noGrp="1"/>
           </p:cNvSpPr>
@@ -2754,7 +2754,7 @@
       </p:grpSpPr>
       <p:sp>
         <p:nvSpPr>
-          <p:cNvPr id="1230250356" name="Title 1"/>
+          <p:cNvPr id="475545105" name="Title 1"/>
           <p:cNvSpPr>
             <a:spLocks noGrp="1"/>
           </p:cNvSpPr>
@@ -2780,7 +2780,7 @@
       </p:sp>
       <p:sp>
         <p:nvSpPr>
-          <p:cNvPr id="1291777511" name="Content Placeholder 2"/>
+          <p:cNvPr id="1953193207" name="Content Placeholder 2"/>
           <p:cNvSpPr>
             <a:spLocks noGrp="1"/>
           </p:cNvSpPr>
@@ -2879,7 +2879,7 @@
       </p:sp>
       <p:sp>
         <p:nvSpPr>
-          <p:cNvPr id="43770311" name="Content Placeholder 3"/>
+          <p:cNvPr id="1996526997" name="Content Placeholder 3"/>
           <p:cNvSpPr>
             <a:spLocks noGrp="1"/>
           </p:cNvSpPr>
@@ -2978,7 +2978,7 @@
       </p:sp>
       <p:sp>
         <p:nvSpPr>
-          <p:cNvPr id="1080866776" name="Date Placeholder 4"/>
+          <p:cNvPr id="762133426" name="Date Placeholder 4"/>
           <p:cNvSpPr>
             <a:spLocks noGrp="1"/>
           </p:cNvSpPr>
@@ -3004,7 +3004,7 @@
       </p:sp>
       <p:sp>
         <p:nvSpPr>
-          <p:cNvPr id="1591843955" name="Footer Placeholder 5"/>
+          <p:cNvPr id="973269336" name="Footer Placeholder 5"/>
           <p:cNvSpPr>
             <a:spLocks noGrp="1"/>
           </p:cNvSpPr>
@@ -3026,7 +3026,7 @@
       </p:sp>
       <p:sp>
         <p:nvSpPr>
-          <p:cNvPr id="1490486843" name="Slide Number Placeholder 6"/>
+          <p:cNvPr id="2095838871" name="Slide Number Placeholder 6"/>
           <p:cNvSpPr>
             <a:spLocks noGrp="1"/>
           </p:cNvSpPr>
@@ -3077,7 +3077,7 @@
       </p:grpSpPr>
       <p:sp>
         <p:nvSpPr>
-          <p:cNvPr id="1036452567" name="Title 1"/>
+          <p:cNvPr id="1732070894" name="Title 1"/>
           <p:cNvSpPr>
             <a:spLocks noGrp="1"/>
           </p:cNvSpPr>
@@ -3107,7 +3107,7 @@
       </p:sp>
       <p:sp>
         <p:nvSpPr>
-          <p:cNvPr id="1850028687" name="Text Placeholder 2"/>
+          <p:cNvPr id="835534535" name="Text Placeholder 2"/>
           <p:cNvSpPr>
             <a:spLocks noGrp="1"/>
           </p:cNvSpPr>
@@ -3175,7 +3175,7 @@
       </p:sp>
       <p:sp>
         <p:nvSpPr>
-          <p:cNvPr id="2115649920" name="Content Placeholder 3"/>
+          <p:cNvPr id="1985342073" name="Content Placeholder 3"/>
           <p:cNvSpPr>
             <a:spLocks noGrp="1"/>
           </p:cNvSpPr>
@@ -3274,7 +3274,7 @@
       </p:sp>
       <p:sp>
         <p:nvSpPr>
-          <p:cNvPr id="113628129" name="Text Placeholder 4"/>
+          <p:cNvPr id="1724218273" name="Text Placeholder 4"/>
           <p:cNvSpPr>
             <a:spLocks noGrp="1"/>
           </p:cNvSpPr>
@@ -3342,7 +3342,7 @@
       </p:sp>
       <p:sp>
         <p:nvSpPr>
-          <p:cNvPr id="1634501940" name="Content Placeholder 5"/>
+          <p:cNvPr id="314662496" name="Content Placeholder 5"/>
           <p:cNvSpPr>
             <a:spLocks noGrp="1"/>
           </p:cNvSpPr>
@@ -3441,7 +3441,7 @@
       </p:sp>
       <p:sp>
         <p:nvSpPr>
-          <p:cNvPr id="789965808" name="Date Placeholder 6"/>
+          <p:cNvPr id="1680136130" name="Date Placeholder 6"/>
           <p:cNvSpPr>
             <a:spLocks noGrp="1"/>
           </p:cNvSpPr>
@@ -3467,7 +3467,7 @@
       </p:sp>
       <p:sp>
         <p:nvSpPr>
-          <p:cNvPr id="1539832180" name="Footer Placeholder 7"/>
+          <p:cNvPr id="90918444" name="Footer Placeholder 7"/>
           <p:cNvSpPr>
             <a:spLocks noGrp="1"/>
           </p:cNvSpPr>
@@ -3489,7 +3489,7 @@
       </p:sp>
       <p:sp>
         <p:nvSpPr>
-          <p:cNvPr id="1553343926" name="Slide Number Placeholder 8"/>
+          <p:cNvPr id="1693398078" name="Slide Number Placeholder 8"/>
           <p:cNvSpPr>
             <a:spLocks noGrp="1"/>
           </p:cNvSpPr>
@@ -3540,7 +3540,7 @@
       </p:grpSpPr>
       <p:sp>
         <p:nvSpPr>
-          <p:cNvPr id="719867485" name="Title 1"/>
+          <p:cNvPr id="530684133" name="Title 1"/>
           <p:cNvSpPr>
             <a:spLocks noGrp="1"/>
           </p:cNvSpPr>
@@ -3566,7 +3566,7 @@
       </p:sp>
       <p:sp>
         <p:nvSpPr>
-          <p:cNvPr id="282351563" name="Date Placeholder 2"/>
+          <p:cNvPr id="1826930044" name="Date Placeholder 2"/>
           <p:cNvSpPr>
             <a:spLocks noGrp="1"/>
           </p:cNvSpPr>
@@ -3592,7 +3592,7 @@
       </p:sp>
       <p:sp>
         <p:nvSpPr>
-          <p:cNvPr id="1784747675" name="Footer Placeholder 3"/>
+          <p:cNvPr id="1509020578" name="Footer Placeholder 3"/>
           <p:cNvSpPr>
             <a:spLocks noGrp="1"/>
           </p:cNvSpPr>
@@ -3614,7 +3614,7 @@
       </p:sp>
       <p:sp>
         <p:nvSpPr>
-          <p:cNvPr id="1438007579" name="Slide Number Placeholder 4"/>
+          <p:cNvPr id="1156279478" name="Slide Number Placeholder 4"/>
           <p:cNvSpPr>
             <a:spLocks noGrp="1"/>
           </p:cNvSpPr>
@@ -3665,7 +3665,7 @@
       </p:grpSpPr>
       <p:sp>
         <p:nvSpPr>
-          <p:cNvPr id="533467813" name="Date Placeholder 1"/>
+          <p:cNvPr id="1984172490" name="Date Placeholder 1"/>
           <p:cNvSpPr>
             <a:spLocks noGrp="1"/>
           </p:cNvSpPr>
@@ -3691,7 +3691,7 @@
       </p:sp>
       <p:sp>
         <p:nvSpPr>
-          <p:cNvPr id="1126242830" name="Footer Placeholder 2"/>
+          <p:cNvPr id="697000451" name="Footer Placeholder 2"/>
           <p:cNvSpPr>
             <a:spLocks noGrp="1"/>
           </p:cNvSpPr>
@@ -3713,7 +3713,7 @@
       </p:sp>
       <p:sp>
         <p:nvSpPr>
-          <p:cNvPr id="1641912548" name="Slide Number Placeholder 3"/>
+          <p:cNvPr id="1283952279" name="Slide Number Placeholder 3"/>
           <p:cNvSpPr>
             <a:spLocks noGrp="1"/>
           </p:cNvSpPr>
@@ -3764,7 +3764,7 @@
       </p:grpSpPr>
       <p:sp>
         <p:nvSpPr>
-          <p:cNvPr id="606184387" name="Title 1"/>
+          <p:cNvPr id="308347858" name="Title 1"/>
           <p:cNvSpPr>
             <a:spLocks noGrp="1"/>
           </p:cNvSpPr>
@@ -3799,7 +3799,7 @@
       </p:sp>
       <p:sp>
         <p:nvSpPr>
-          <p:cNvPr id="12939742" name="Content Placeholder 2"/>
+          <p:cNvPr id="1461374359" name="Content Placeholder 2"/>
           <p:cNvSpPr>
             <a:spLocks noGrp="1"/>
           </p:cNvSpPr>
@@ -3898,7 +3898,7 @@
       </p:sp>
       <p:sp>
         <p:nvSpPr>
-          <p:cNvPr id="2062475266" name="Text Placeholder 3"/>
+          <p:cNvPr id="505227304" name="Text Placeholder 3"/>
           <p:cNvSpPr>
             <a:spLocks noGrp="1"/>
           </p:cNvSpPr>
@@ -3966,7 +3966,7 @@
       </p:sp>
       <p:sp>
         <p:nvSpPr>
-          <p:cNvPr id="1719641023" name="Date Placeholder 4"/>
+          <p:cNvPr id="1002674165" name="Date Placeholder 4"/>
           <p:cNvSpPr>
             <a:spLocks noGrp="1"/>
           </p:cNvSpPr>
@@ -3992,7 +3992,7 @@
       </p:sp>
       <p:sp>
         <p:nvSpPr>
-          <p:cNvPr id="286859102" name="Footer Placeholder 5"/>
+          <p:cNvPr id="111371540" name="Footer Placeholder 5"/>
           <p:cNvSpPr>
             <a:spLocks noGrp="1"/>
           </p:cNvSpPr>
@@ -4014,7 +4014,7 @@
       </p:sp>
       <p:sp>
         <p:nvSpPr>
-          <p:cNvPr id="808387972" name="Slide Number Placeholder 6"/>
+          <p:cNvPr id="13038256" name="Slide Number Placeholder 6"/>
           <p:cNvSpPr>
             <a:spLocks noGrp="1"/>
           </p:cNvSpPr>
@@ -4065,7 +4065,7 @@
       </p:grpSpPr>
       <p:sp>
         <p:nvSpPr>
-          <p:cNvPr id="1535481226" name="Title 1"/>
+          <p:cNvPr id="1879680867" name="Title 1"/>
           <p:cNvSpPr>
             <a:spLocks noGrp="1"/>
           </p:cNvSpPr>
@@ -4100,7 +4100,7 @@
       </p:sp>
       <p:sp>
         <p:nvSpPr>
-          <p:cNvPr id="978607701" name="Picture Placeholder 2"/>
+          <p:cNvPr id="793411334" name="Picture Placeholder 2"/>
           <p:cNvSpPr>
             <a:spLocks noGrp="1"/>
           </p:cNvSpPr>
@@ -4164,7 +4164,7 @@
       </p:sp>
       <p:sp>
         <p:nvSpPr>
-          <p:cNvPr id="1969235468" name="Text Placeholder 3"/>
+          <p:cNvPr id="1692327751" name="Text Placeholder 3"/>
           <p:cNvSpPr>
             <a:spLocks noGrp="1"/>
           </p:cNvSpPr>
@@ -4232,7 +4232,7 @@
       </p:sp>
       <p:sp>
         <p:nvSpPr>
-          <p:cNvPr id="2067868597" name="Date Placeholder 4"/>
+          <p:cNvPr id="575935488" name="Date Placeholder 4"/>
           <p:cNvSpPr>
             <a:spLocks noGrp="1"/>
           </p:cNvSpPr>
@@ -4258,7 +4258,7 @@
       </p:sp>
       <p:sp>
         <p:nvSpPr>
-          <p:cNvPr id="129814206" name="Footer Placeholder 5"/>
+          <p:cNvPr id="1391933202" name="Footer Placeholder 5"/>
           <p:cNvSpPr>
             <a:spLocks noGrp="1"/>
           </p:cNvSpPr>
@@ -4280,7 +4280,7 @@
       </p:sp>
       <p:sp>
         <p:nvSpPr>
-          <p:cNvPr id="1481777667" name="Slide Number Placeholder 6"/>
+          <p:cNvPr id="434267041" name="Slide Number Placeholder 6"/>
           <p:cNvSpPr>
             <a:spLocks noGrp="1"/>
           </p:cNvSpPr>
@@ -4336,7 +4336,7 @@
       </p:grpSpPr>
       <p:sp>
         <p:nvSpPr>
-          <p:cNvPr id="1204460982" name="Shape 1059"/>
+          <p:cNvPr id="957248409" name="Shape 1059"/>
           <p:cNvSpPr>
             <a:spLocks noChangeArrowheads="1" noGrp="1"/>
           </p:cNvSpPr>
@@ -4414,7 +4414,7 @@
       </p:sp>
       <p:sp>
         <p:nvSpPr>
-          <p:cNvPr id="1777853965" name="Shape 1060"/>
+          <p:cNvPr id="574815629" name="Shape 1060"/>
           <p:cNvSpPr>
             <a:spLocks noChangeArrowheads="1" noGrp="1"/>
           </p:cNvSpPr>
@@ -4495,7 +4495,7 @@
       </p:sp>
       <p:sp>
         <p:nvSpPr>
-          <p:cNvPr id="1077272611" name="Shape 1061"/>
+          <p:cNvPr id="296895477" name="Shape 1061"/>
           <p:cNvSpPr>
             <a:spLocks noChangeArrowheads="1" noGrp="1"/>
           </p:cNvSpPr>
@@ -4613,7 +4613,7 @@
       </p:sp>
       <p:sp>
         <p:nvSpPr>
-          <p:cNvPr id="1711158617" name="Title 1"/>
+          <p:cNvPr id="973102475" name="Title 1"/>
           <p:cNvSpPr>
             <a:spLocks noGrp="1"/>
           </p:cNvSpPr>
@@ -4649,7 +4649,7 @@
       </p:sp>
       <p:sp>
         <p:nvSpPr>
-          <p:cNvPr id="78878338" name="Text Placeholder 2"/>
+          <p:cNvPr id="1224905521" name="Text Placeholder 2"/>
           <p:cNvSpPr>
             <a:spLocks noGrp="1"/>
           </p:cNvSpPr>
@@ -4725,7 +4725,7 @@
       </p:sp>
       <p:sp>
         <p:nvSpPr>
-          <p:cNvPr id="631219386" name="Date Placeholder 3"/>
+          <p:cNvPr id="1395512220" name="Date Placeholder 3"/>
           <p:cNvSpPr>
             <a:spLocks noGrp="1"/>
           </p:cNvSpPr>
@@ -4769,7 +4769,7 @@
       </p:sp>
       <p:sp>
         <p:nvSpPr>
-          <p:cNvPr id="594836196" name="Footer Placeholder 4"/>
+          <p:cNvPr id="387165738" name="Footer Placeholder 4"/>
           <p:cNvSpPr>
             <a:spLocks noGrp="1"/>
           </p:cNvSpPr>
@@ -4809,7 +4809,7 @@
       </p:sp>
       <p:sp>
         <p:nvSpPr>
-          <p:cNvPr id="834925694" name="Slide Number Placeholder 5"/>
+          <p:cNvPr id="142185680" name="Slide Number Placeholder 5"/>
           <p:cNvSpPr>
             <a:spLocks noGrp="1"/>
           </p:cNvSpPr>
@@ -5157,7 +5157,7 @@
       </p:grpSpPr>
       <p:sp>
         <p:nvSpPr>
-          <p:cNvPr id="1371980970" name="Title 1"/>
+          <p:cNvPr id="1830903448" name="Title 1"/>
           <p:cNvSpPr>
             <a:spLocks noGrp="1"/>
           </p:cNvSpPr>
@@ -5194,7 +5194,7 @@
       </p:sp>
       <p:sp>
         <p:nvSpPr>
-          <p:cNvPr id="1857255546" name=""/>
+          <p:cNvPr id="784156903" name=""/>
           <p:cNvSpPr txBox="1"/>
           <p:nvPr/>
         </p:nvSpPr>
@@ -5259,7 +5259,7 @@
       </p:grpSpPr>
       <p:sp>
         <p:nvSpPr>
-          <p:cNvPr id="2028549918" name="Title 1"/>
+          <p:cNvPr id="595566467" name="Title 1"/>
           <p:cNvSpPr>
             <a:spLocks noGrp="1"/>
           </p:cNvSpPr>
@@ -5285,7 +5285,7 @@
       </p:sp>
       <p:sp>
         <p:nvSpPr>
-          <p:cNvPr id="1760248315" name="Content Placeholder 2"/>
+          <p:cNvPr id="1432011619" name="Content Placeholder 2"/>
           <p:cNvSpPr>
             <a:spLocks noGrp="1"/>
           </p:cNvSpPr>
@@ -5631,7 +5631,7 @@
       </p:grpSpPr>
       <p:sp>
         <p:nvSpPr>
-          <p:cNvPr id="1182122045" name="Title 1"/>
+          <p:cNvPr id="486204928" name="Title 1"/>
           <p:cNvSpPr>
             <a:spLocks noGrp="1"/>
           </p:cNvSpPr>
@@ -5657,7 +5657,7 @@
       </p:sp>
       <p:sp>
         <p:nvSpPr>
-          <p:cNvPr id="654552801" name="Content Placeholder 2"/>
+          <p:cNvPr id="1080006023" name="Content Placeholder 2"/>
           <p:cNvSpPr>
             <a:spLocks noGrp="1"/>
           </p:cNvSpPr>
@@ -6055,7 +6055,7 @@
       </p:grpSpPr>
       <p:pic>
         <p:nvPicPr>
-          <p:cNvPr id="477174955" name=""/>
+          <p:cNvPr id="1768872505" name=""/>
           <p:cNvPicPr>
             <a:picLocks noChangeAspect="1"/>
           </p:cNvPicPr>
@@ -6078,7 +6078,7 @@
       </p:pic>
       <p:pic>
         <p:nvPicPr>
-          <p:cNvPr id="2143642338" name=""/>
+          <p:cNvPr id="342781456" name=""/>
           <p:cNvPicPr>
             <a:picLocks noChangeAspect="1"/>
           </p:cNvPicPr>
@@ -6100,7 +6100,7 @@
       </p:pic>
       <p:cxnSp>
         <p:nvCxnSpPr>
-          <p:cNvPr id="2131479040" name=""/>
+          <p:cNvPr id="158008989" name=""/>
           <p:cNvCxnSpPr/>
           <p:nvPr/>
         </p:nvCxnSpPr>
@@ -6138,7 +6138,7 @@
       </p:cxnSp>
       <p:sp>
         <p:nvSpPr>
-          <p:cNvPr id="51722391" name=""/>
+          <p:cNvPr id="1143996514" name=""/>
           <p:cNvSpPr txBox="1"/>
           <p:nvPr/>
         </p:nvSpPr>
@@ -6211,7 +6211,7 @@
       </p:grpSpPr>
       <p:pic>
         <p:nvPicPr>
-          <p:cNvPr id="1264313683" name=""/>
+          <p:cNvPr id="779806149" name=""/>
           <p:cNvPicPr>
             <a:picLocks noChangeAspect="1"/>
           </p:cNvPicPr>
@@ -6233,7 +6233,7 @@
       </p:pic>
       <p:pic>
         <p:nvPicPr>
-          <p:cNvPr id="331209014" name=""/>
+          <p:cNvPr id="603906235" name=""/>
           <p:cNvPicPr>
             <a:picLocks noChangeAspect="1"/>
           </p:cNvPicPr>
@@ -6288,7 +6288,7 @@
       </p:grpSpPr>
       <p:pic>
         <p:nvPicPr>
-          <p:cNvPr id="651888298" name=""/>
+          <p:cNvPr id="668604239" name=""/>
           <p:cNvPicPr>
             <a:picLocks noChangeAspect="1"/>
           </p:cNvPicPr>
@@ -6310,7 +6310,7 @@
       </p:pic>
       <p:pic>
         <p:nvPicPr>
-          <p:cNvPr id="915616986" name=""/>
+          <p:cNvPr id="1214223801" name=""/>
           <p:cNvPicPr>
             <a:picLocks noChangeAspect="1"/>
           </p:cNvPicPr>
@@ -6365,7 +6365,7 @@
       </p:grpSpPr>
       <p:pic>
         <p:nvPicPr>
-          <p:cNvPr id="1576110808" name=""/>
+          <p:cNvPr id="1540925010" name=""/>
           <p:cNvPicPr>
             <a:picLocks noChangeAspect="1"/>
           </p:cNvPicPr>
@@ -6420,7 +6420,7 @@
       </p:grpSpPr>
       <p:sp>
         <p:nvSpPr>
-          <p:cNvPr id="1999335196" name="Title 1"/>
+          <p:cNvPr id="1251154008" name="Title 1"/>
           <p:cNvSpPr>
             <a:spLocks noGrp="1"/>
           </p:cNvSpPr>
@@ -6450,7 +6450,7 @@
       </p:sp>
       <p:sp>
         <p:nvSpPr>
-          <p:cNvPr id="1766793986" name="Content Placeholder 2"/>
+          <p:cNvPr id="560573566" name="Content Placeholder 2"/>
           <p:cNvSpPr>
             <a:spLocks noGrp="1"/>
           </p:cNvSpPr>
@@ -6461,7 +6461,7 @@
         <p:spPr bwMode="auto"/>
         <p:txBody>
           <a:bodyPr vertOverflow="overflow" horzOverflow="overflow" vert="horz" wrap="square" lIns="91440" tIns="45720" rIns="91440" bIns="45720" numCol="1" spcCol="0" rtlCol="0" fromWordArt="0" anchor="t" anchorCtr="0" forceAA="0" upright="0" compatLnSpc="0">
-            <a:normAutofit/>
+            <a:normAutofit fontScale="90000" lnSpcReduction="2000"/>
           </a:bodyPr>
           <a:lstStyle/>
           <a:p>
@@ -6690,6 +6690,36 @@
                 <a:cs typeface="Arial"/>
               </a:rPr>
               <a:t>+1 untuk masing-masing komentar/tanya jawab (maks 5)</a:t>
+            </a:r>
+            <a:endParaRPr lang="en-US" sz="3200" b="0" i="0" u="none" strike="noStrike" cap="none" spc="0">
+              <a:solidFill>
+                <a:schemeClr val="tx1">
+                  <a:lumMod val="75000"/>
+                  <a:lumOff val="25000"/>
+                </a:schemeClr>
+              </a:solidFill>
+              <a:latin typeface="Arial"/>
+              <a:ea typeface="Arial"/>
+              <a:cs typeface="Arial"/>
+            </a:endParaRPr>
+          </a:p>
+          <a:p>
+            <a:pPr>
+              <a:defRPr/>
+            </a:pPr>
+            <a:r>
+              <a:rPr lang="en-US" sz="3200" b="0" i="0" u="none" strike="noStrike" cap="none" spc="0">
+                <a:solidFill>
+                  <a:schemeClr val="tx1">
+                    <a:lumMod val="75000"/>
+                    <a:lumOff val="25000"/>
+                  </a:schemeClr>
+                </a:solidFill>
+                <a:latin typeface="Arial"/>
+                <a:ea typeface="Arial"/>
+                <a:cs typeface="Arial"/>
+              </a:rPr>
+              <a:t>-1 untuk tidak memberikan penilaian</a:t>
             </a:r>
             <a:endParaRPr sz="3200" b="0" i="0" u="none" strike="noStrike" cap="none" spc="0">
               <a:solidFill>

</xml_diff>